<commit_message>
Retrace the taiaha from reference and correct the mark
The earlier silhouette was too short and bulbous. Redrawn from measured
half-widths: a long leaf-shaped arero, a barely wider carved upoko, a
very fine ate and a gradually widening rau. At true proportions the shaft
is about one fiftieth of the length, so the mark carries the arero and
upoko with the collar binding as the red accent, and the whole weapon is
shown only to explain that choice.

Co-Authored-By: Claude Fable 5 <noreply@anthropic.com>
Claude-Session: https://claude.ai/code/session_01YLo1WfwUDkbwfJEF3ZNVbB
</commit_message>
<xml_diff>
--- a/output/combat-mindset-brandmark-taiaha.pptx
+++ b/output/combat-mindset-brandmark-taiaha.pptx
@@ -2233,7 +2233,7 @@
                 <a:ea typeface="Arial" pitchFamily="34" charset="-122"/>
                 <a:cs typeface="Arial" pitchFamily="34" charset="-120"/>
               </a:rPr>
-              <a:t>VARIANT: THE HEAD ALONE</a:t>
+              <a:t>WHY THE HEAD, NOT THE WHOLE WEAPON</a:t>
             </a:r>
             <a:endParaRPr lang="en-US" sz="760" dirty="0"/>
           </a:p>
@@ -2368,7 +2368,7 @@
                 <a:ea typeface="Arial" pitchFamily="34" charset="-122"/>
                 <a:cs typeface="Arial" pitchFamily="34" charset="-120"/>
               </a:rPr>
-              <a:t>The full taiaha carries more meaning, but its shaft is slim and the first thing to disappear when the mark is reduced. Cutting the arero and upoko alone keeps the reference and gains weight. Worth holding as the small-size variant if the full weapon proves too fine below about 12 mm.</a:t>
+              <a:t>Drawn to true proportions the taiaha is very slender: the ate is roughly one fiftieth of its length. At badge size that shaft becomes a hairline and the weapon reads as a stick. The mark therefore carries the arero and upoko, the part that is unmistakably a taiaha, with the collar binding struck in red.</a:t>
             </a:r>
             <a:endParaRPr lang="en-US" sz="840" dirty="0"/>
           </a:p>

</xml_diff>